<commit_message>
updated presentations and video
</commit_message>
<xml_diff>
--- a/report/KhannaD_AIH_HRP_Presentation.pptx
+++ b/report/KhannaD_AIH_HRP_Presentation.pptx
@@ -2710,6 +2710,14 @@
   <p:clrMapOvr>
     <a:masterClrMapping/>
   </p:clrMapOvr>
+  <mc:AlternateContent xmlns:mc="http://schemas.openxmlformats.org/markup-compatibility/2006" xmlns:p14="http://schemas.microsoft.com/office/powerpoint/2010/main">
+    <mc:Choice Requires="p14">
+      <p:transition spd="slow" p14:dur="2000" advTm="36770"/>
+    </mc:Choice>
+    <mc:Fallback xmlns="">
+      <p:transition spd="slow" advTm="36770"/>
+    </mc:Fallback>
+  </mc:AlternateContent>
 </p:sld>
 </file>
 
@@ -4087,6 +4095,14 @@
   <p:clrMapOvr>
     <a:masterClrMapping/>
   </p:clrMapOvr>
+  <mc:AlternateContent xmlns:mc="http://schemas.openxmlformats.org/markup-compatibility/2006" xmlns:p14="http://schemas.microsoft.com/office/powerpoint/2010/main">
+    <mc:Choice Requires="p14">
+      <p:transition spd="slow" p14:dur="2000" advTm="43205"/>
+    </mc:Choice>
+    <mc:Fallback xmlns="">
+      <p:transition spd="slow" advTm="43205"/>
+    </mc:Fallback>
+  </mc:AlternateContent>
 </p:sld>
 </file>
 
@@ -4975,6 +4991,14 @@
   <p:clrMapOvr>
     <a:masterClrMapping/>
   </p:clrMapOvr>
+  <mc:AlternateContent xmlns:mc="http://schemas.openxmlformats.org/markup-compatibility/2006" xmlns:p14="http://schemas.microsoft.com/office/powerpoint/2010/main">
+    <mc:Choice Requires="p14">
+      <p:transition spd="slow" p14:dur="2000" advTm="19802"/>
+    </mc:Choice>
+    <mc:Fallback xmlns="">
+      <p:transition spd="slow" advTm="19802"/>
+    </mc:Fallback>
+  </mc:AlternateContent>
 </p:sld>
 </file>
 
@@ -6024,6 +6048,14 @@
   <p:clrMapOvr>
     <a:masterClrMapping/>
   </p:clrMapOvr>
+  <mc:AlternateContent xmlns:mc="http://schemas.openxmlformats.org/markup-compatibility/2006" xmlns:p14="http://schemas.microsoft.com/office/powerpoint/2010/main">
+    <mc:Choice Requires="p14">
+      <p:transition spd="slow" p14:dur="2000" advTm="70551"/>
+    </mc:Choice>
+    <mc:Fallback xmlns="">
+      <p:transition spd="slow" advTm="70551"/>
+    </mc:Fallback>
+  </mc:AlternateContent>
 </p:sld>
 </file>
 
@@ -7007,6 +7039,14 @@
   <p:clrMapOvr>
     <a:masterClrMapping/>
   </p:clrMapOvr>
+  <mc:AlternateContent xmlns:mc="http://schemas.openxmlformats.org/markup-compatibility/2006" xmlns:p14="http://schemas.microsoft.com/office/powerpoint/2010/main">
+    <mc:Choice Requires="p14">
+      <p:transition spd="slow" p14:dur="2000" advTm="72508"/>
+    </mc:Choice>
+    <mc:Fallback xmlns="">
+      <p:transition spd="slow" advTm="72508"/>
+    </mc:Fallback>
+  </mc:AlternateContent>
 </p:sld>
 </file>
 
@@ -8805,6 +8845,14 @@
   <p:clrMapOvr>
     <a:masterClrMapping/>
   </p:clrMapOvr>
+  <mc:AlternateContent xmlns:mc="http://schemas.openxmlformats.org/markup-compatibility/2006" xmlns:p14="http://schemas.microsoft.com/office/powerpoint/2010/main">
+    <mc:Choice Requires="p14">
+      <p:transition spd="slow" p14:dur="2000" advTm="59140"/>
+    </mc:Choice>
+    <mc:Fallback xmlns="">
+      <p:transition spd="slow" advTm="59140"/>
+    </mc:Fallback>
+  </mc:AlternateContent>
 </p:sld>
 </file>
 
@@ -9190,6 +9238,14 @@
   <p:clrMapOvr>
     <a:masterClrMapping/>
   </p:clrMapOvr>
+  <mc:AlternateContent xmlns:mc="http://schemas.openxmlformats.org/markup-compatibility/2006" xmlns:p14="http://schemas.microsoft.com/office/powerpoint/2010/main">
+    <mc:Choice Requires="p14">
+      <p:transition spd="slow" p14:dur="2000" advTm="50207"/>
+    </mc:Choice>
+    <mc:Fallback xmlns="">
+      <p:transition spd="slow" advTm="50207"/>
+    </mc:Fallback>
+  </mc:AlternateContent>
 </p:sld>
 </file>
 
@@ -9911,6 +9967,14 @@
   <p:clrMapOvr>
     <a:masterClrMapping/>
   </p:clrMapOvr>
+  <mc:AlternateContent xmlns:mc="http://schemas.openxmlformats.org/markup-compatibility/2006" xmlns:p14="http://schemas.microsoft.com/office/powerpoint/2010/main">
+    <mc:Choice Requires="p14">
+      <p:transition spd="slow" p14:dur="2000" advTm="64240"/>
+    </mc:Choice>
+    <mc:Fallback xmlns="">
+      <p:transition spd="slow" advTm="64240"/>
+    </mc:Fallback>
+  </mc:AlternateContent>
 </p:sld>
 </file>
 
@@ -11562,6 +11626,14 @@
   <p:clrMapOvr>
     <a:masterClrMapping/>
   </p:clrMapOvr>
+  <mc:AlternateContent xmlns:mc="http://schemas.openxmlformats.org/markup-compatibility/2006" xmlns:p14="http://schemas.microsoft.com/office/powerpoint/2010/main">
+    <mc:Choice Requires="p14">
+      <p:transition spd="slow" p14:dur="2000" advTm="70343"/>
+    </mc:Choice>
+    <mc:Fallback xmlns="">
+      <p:transition spd="slow" advTm="70343"/>
+    </mc:Fallback>
+  </mc:AlternateContent>
 </p:sld>
 </file>
 
@@ -12448,6 +12520,14 @@
   <p:clrMapOvr>
     <a:masterClrMapping/>
   </p:clrMapOvr>
+  <mc:AlternateContent xmlns:mc="http://schemas.openxmlformats.org/markup-compatibility/2006" xmlns:p14="http://schemas.microsoft.com/office/powerpoint/2010/main">
+    <mc:Choice Requires="p14">
+      <p:transition spd="slow" p14:dur="2000" advTm="53306"/>
+    </mc:Choice>
+    <mc:Fallback xmlns="">
+      <p:transition spd="slow" advTm="53306"/>
+    </mc:Fallback>
+  </mc:AlternateContent>
 </p:sld>
 </file>
 
@@ -13198,6 +13278,14 @@
   <p:clrMapOvr>
     <a:masterClrMapping/>
   </p:clrMapOvr>
+  <mc:AlternateContent xmlns:mc="http://schemas.openxmlformats.org/markup-compatibility/2006" xmlns:p14="http://schemas.microsoft.com/office/powerpoint/2010/main">
+    <mc:Choice Requires="p14">
+      <p:transition spd="slow" p14:dur="2000" advTm="41871"/>
+    </mc:Choice>
+    <mc:Fallback xmlns="">
+      <p:transition spd="slow" advTm="41871"/>
+    </mc:Fallback>
+  </mc:AlternateContent>
 </p:sld>
 </file>
 

</xml_diff>